<commit_message>
added matchingName slide layout for future tests
</commit_message>
<xml_diff>
--- a/cmd/pptx-toolkit/testdata/test.pptx
+++ b/cmd/pptx-toolkit/testdata/test.pptx
@@ -12895,7 +12895,7 @@
           <a:p>
             <a:fld id="{A19F28EB-6B0E-3A46-A4A7-9B1BCB3FCA6C}" type="datetimeFigureOut">
               <a:rPr lang="en-US" smtClean="0"/>
-              <a:t>10/26/25</a:t>
+              <a:t>5/6/26</a:t>
             </a:fld>
             <a:endParaRPr lang="en-US"/>
           </a:p>
@@ -13072,7 +13072,7 @@
           <a:p>
             <a:fld id="{7E20784D-5404-1445-90FD-0AA61620D67E}" type="datetimeFigureOut">
               <a:rPr lang="en-US" smtClean="0"/>
-              <a:t>10/26/25</a:t>
+              <a:t>5/6/26</a:t>
             </a:fld>
             <a:endParaRPr lang="en-US"/>
           </a:p>
@@ -13577,7 +13577,7 @@
           <a:p>
             <a:fld id="{99FB2E88-1E27-2243-AE12-8E9276940C7E}" type="datetimeFigureOut">
               <a:rPr lang="en-US" smtClean="0"/>
-              <a:t>10/26/25</a:t>
+              <a:t>5/6/26</a:t>
             </a:fld>
             <a:endParaRPr lang="en-US"/>
           </a:p>
@@ -13777,7 +13777,7 @@
           <a:p>
             <a:fld id="{99FB2E88-1E27-2243-AE12-8E9276940C7E}" type="datetimeFigureOut">
               <a:rPr lang="en-US" smtClean="0"/>
-              <a:t>10/26/25</a:t>
+              <a:t>5/6/26</a:t>
             </a:fld>
             <a:endParaRPr lang="en-US"/>
           </a:p>
@@ -13987,7 +13987,7 @@
           <a:p>
             <a:fld id="{99FB2E88-1E27-2243-AE12-8E9276940C7E}" type="datetimeFigureOut">
               <a:rPr lang="en-US" smtClean="0"/>
-              <a:t>10/26/25</a:t>
+              <a:t>5/6/26</a:t>
             </a:fld>
             <a:endParaRPr lang="en-US"/>
           </a:p>
@@ -14061,6 +14061,306 @@
 </file>
 
 <file path=ppt/slideLayouts/slideLayout12.xml><?xml version="1.0" encoding="utf-8"?>
+<p:sldLayout xmlns:a="http://schemas.openxmlformats.org/drawingml/2006/main" xmlns:r="http://schemas.openxmlformats.org/officeDocument/2006/relationships" xmlns:p="http://schemas.openxmlformats.org/presentationml/2006/main" matchingName="Layout with matchName property" preserve="1" userDrawn="1">
+  <p:cSld name="matchName-test">
+    <p:spTree>
+      <p:nvGrpSpPr>
+        <p:cNvPr id="1" name=""/>
+        <p:cNvGrpSpPr/>
+        <p:nvPr/>
+      </p:nvGrpSpPr>
+      <p:grpSpPr>
+        <a:xfrm>
+          <a:off x="0" y="0"/>
+          <a:ext cx="0" cy="0"/>
+          <a:chOff x="0" y="0"/>
+          <a:chExt cx="0" cy="0"/>
+        </a:xfrm>
+      </p:grpSpPr>
+      <p:sp>
+        <p:nvSpPr>
+          <p:cNvPr id="2" name="Title 1">
+            <a:extLst>
+              <a:ext uri="{FF2B5EF4-FFF2-40B4-BE49-F238E27FC236}">
+                <a16:creationId xmlns:a16="http://schemas.microsoft.com/office/drawing/2014/main" id="{C69E5C78-9429-FB00-0C72-4DBACFDF8D5A}"/>
+              </a:ext>
+            </a:extLst>
+          </p:cNvPr>
+          <p:cNvSpPr>
+            <a:spLocks noGrp="1"/>
+          </p:cNvSpPr>
+          <p:nvPr>
+            <p:ph type="title"/>
+          </p:nvPr>
+        </p:nvSpPr>
+        <p:spPr/>
+        <p:txBody>
+          <a:bodyPr/>
+          <a:lstStyle/>
+          <a:p>
+            <a:r>
+              <a:rPr lang="en-GB" dirty="0"/>
+              <a:t>Click to edit Master title style</a:t>
+            </a:r>
+          </a:p>
+        </p:txBody>
+      </p:sp>
+      <p:sp>
+        <p:nvSpPr>
+          <p:cNvPr id="3" name="Date Placeholder 2">
+            <a:extLst>
+              <a:ext uri="{FF2B5EF4-FFF2-40B4-BE49-F238E27FC236}">
+                <a16:creationId xmlns:a16="http://schemas.microsoft.com/office/drawing/2014/main" id="{23102A21-FEAB-B77A-77E9-8EAC78BAA35F}"/>
+              </a:ext>
+            </a:extLst>
+          </p:cNvPr>
+          <p:cNvSpPr>
+            <a:spLocks noGrp="1"/>
+          </p:cNvSpPr>
+          <p:nvPr>
+            <p:ph type="dt" sz="half" idx="10"/>
+          </p:nvPr>
+        </p:nvSpPr>
+        <p:spPr/>
+        <p:txBody>
+          <a:bodyPr/>
+          <a:lstStyle/>
+          <a:p>
+            <a:fld id="{99FB2E88-1E27-2243-AE12-8E9276940C7E}" type="datetimeFigureOut">
+              <a:rPr lang="en-US" smtClean="0"/>
+              <a:t>5/6/26</a:t>
+            </a:fld>
+            <a:endParaRPr lang="en-US"/>
+          </a:p>
+        </p:txBody>
+      </p:sp>
+      <p:sp>
+        <p:nvSpPr>
+          <p:cNvPr id="4" name="Footer Placeholder 3">
+            <a:extLst>
+              <a:ext uri="{FF2B5EF4-FFF2-40B4-BE49-F238E27FC236}">
+                <a16:creationId xmlns:a16="http://schemas.microsoft.com/office/drawing/2014/main" id="{0677E4CA-AFF5-77A3-2B5F-11848E7149C6}"/>
+              </a:ext>
+            </a:extLst>
+          </p:cNvPr>
+          <p:cNvSpPr>
+            <a:spLocks noGrp="1"/>
+          </p:cNvSpPr>
+          <p:nvPr>
+            <p:ph type="ftr" sz="quarter" idx="11"/>
+          </p:nvPr>
+        </p:nvSpPr>
+        <p:spPr/>
+        <p:txBody>
+          <a:bodyPr/>
+          <a:lstStyle/>
+          <a:p>
+            <a:endParaRPr lang="en-US"/>
+          </a:p>
+        </p:txBody>
+      </p:sp>
+      <p:sp>
+        <p:nvSpPr>
+          <p:cNvPr id="5" name="Slide Number Placeholder 4">
+            <a:extLst>
+              <a:ext uri="{FF2B5EF4-FFF2-40B4-BE49-F238E27FC236}">
+                <a16:creationId xmlns:a16="http://schemas.microsoft.com/office/drawing/2014/main" id="{D1199CF7-1582-D633-5DF6-8D957BABC064}"/>
+              </a:ext>
+            </a:extLst>
+          </p:cNvPr>
+          <p:cNvSpPr>
+            <a:spLocks noGrp="1"/>
+          </p:cNvSpPr>
+          <p:nvPr>
+            <p:ph type="sldNum" sz="quarter" idx="12"/>
+          </p:nvPr>
+        </p:nvSpPr>
+        <p:spPr/>
+        <p:txBody>
+          <a:bodyPr/>
+          <a:lstStyle/>
+          <a:p>
+            <a:fld id="{FB79F54A-05CE-C64E-B4BD-9FE99FCAD8A2}" type="slidenum">
+              <a:rPr lang="en-US" smtClean="0"/>
+              <a:t>‹#›</a:t>
+            </a:fld>
+            <a:endParaRPr lang="en-US"/>
+          </a:p>
+        </p:txBody>
+      </p:sp>
+      <p:sp>
+        <p:nvSpPr>
+          <p:cNvPr id="7" name="Text Placeholder 6">
+            <a:extLst>
+              <a:ext uri="{FF2B5EF4-FFF2-40B4-BE49-F238E27FC236}">
+                <a16:creationId xmlns:a16="http://schemas.microsoft.com/office/drawing/2014/main" id="{B9E1C41C-4B9E-44C4-B27A-94141434A929}"/>
+              </a:ext>
+            </a:extLst>
+          </p:cNvPr>
+          <p:cNvSpPr>
+            <a:spLocks noGrp="1"/>
+          </p:cNvSpPr>
+          <p:nvPr>
+            <p:ph type="body" sz="quarter" idx="13" hasCustomPrompt="1"/>
+          </p:nvPr>
+        </p:nvSpPr>
+        <p:spPr>
+          <a:xfrm>
+            <a:off x="1350169" y="2232025"/>
+            <a:ext cx="9491662" cy="2393950"/>
+          </a:xfrm>
+        </p:spPr>
+        <p:txBody>
+          <a:bodyPr/>
+          <a:lstStyle>
+            <a:lvl1pPr marL="228600" marR="0" indent="-228600" algn="ctr" defTabSz="914400" rtl="0" eaLnBrk="1" fontAlgn="auto" latinLnBrk="0" hangingPunct="1">
+              <a:lnSpc>
+                <a:spcPct val="90000"/>
+              </a:lnSpc>
+              <a:spcBef>
+                <a:spcPts val="1000"/>
+              </a:spcBef>
+              <a:spcAft>
+                <a:spcPts val="0"/>
+              </a:spcAft>
+              <a:buClrTx/>
+              <a:buSzTx/>
+              <a:buFont typeface="Arial" panose="020B0604020202020204" pitchFamily="34" charset="0"/>
+              <a:buNone/>
+              <a:tabLst/>
+              <a:defRPr lang="en-IE" sz="2800" b="0" kern="1200" dirty="0" smtClean="0">
+                <a:solidFill>
+                  <a:schemeClr val="tx1"/>
+                </a:solidFill>
+                <a:effectLst/>
+                <a:latin typeface="+mn-lt"/>
+                <a:ea typeface="+mn-ea"/>
+                <a:cs typeface="+mn-cs"/>
+              </a:defRPr>
+            </a:lvl1pPr>
+          </a:lstStyle>
+          <a:p>
+            <a:pPr lvl="0"/>
+            <a:r>
+              <a:rPr lang="en-GB" dirty="0"/>
+              <a:t>This slide layout contains the property:</a:t>
+            </a:r>
+          </a:p>
+          <a:p>
+            <a:pPr marL="228600" marR="0" lvl="0" indent="-228600" algn="ctr" defTabSz="914400" rtl="0" eaLnBrk="1" fontAlgn="auto" latinLnBrk="0" hangingPunct="1">
+              <a:lnSpc>
+                <a:spcPct val="90000"/>
+              </a:lnSpc>
+              <a:spcBef>
+                <a:spcPts val="1000"/>
+              </a:spcBef>
+              <a:spcAft>
+                <a:spcPts val="0"/>
+              </a:spcAft>
+              <a:buClrTx/>
+              <a:buSzTx/>
+              <a:buFont typeface="Arial" panose="020B0604020202020204" pitchFamily="34" charset="0"/>
+              <a:buNone/>
+              <a:tabLst/>
+              <a:defRPr/>
+            </a:pPr>
+            <a:r>
+              <a:rPr lang="en-IE" b="0" dirty="0" err="1">
+                <a:solidFill>
+                  <a:srgbClr val="56B6C2"/>
+                </a:solidFill>
+                <a:effectLst/>
+                <a:latin typeface="Menlo" panose="020B0609030804020204" pitchFamily="49" charset="0"/>
+              </a:rPr>
+              <a:t>p:sldLayout</a:t>
+            </a:r>
+            <a:r>
+              <a:rPr lang="en-IE" b="0" dirty="0">
+                <a:solidFill>
+                  <a:srgbClr val="56B6C2"/>
+                </a:solidFill>
+                <a:effectLst/>
+                <a:latin typeface="Menlo" panose="020B0609030804020204" pitchFamily="49" charset="0"/>
+              </a:rPr>
+              <a:t>/@</a:t>
+            </a:r>
+            <a:r>
+              <a:rPr lang="en-IE" b="0" dirty="0" err="1">
+                <a:solidFill>
+                  <a:srgbClr val="56B6C2"/>
+                </a:solidFill>
+                <a:effectLst/>
+                <a:latin typeface="Menlo" panose="020B0609030804020204" pitchFamily="49" charset="0"/>
+              </a:rPr>
+              <a:t>matchingName</a:t>
+            </a:r>
+            <a:endParaRPr lang="en-IE" b="0" dirty="0">
+              <a:solidFill>
+                <a:srgbClr val="56B6C2"/>
+              </a:solidFill>
+              <a:effectLst/>
+              <a:latin typeface="Menlo" panose="020B0609030804020204" pitchFamily="49" charset="0"/>
+            </a:endParaRPr>
+          </a:p>
+          <a:p>
+            <a:pPr marL="228600" marR="0" lvl="0" indent="-228600" algn="ctr" defTabSz="914400" rtl="0" eaLnBrk="1" fontAlgn="auto" latinLnBrk="0" hangingPunct="1">
+              <a:lnSpc>
+                <a:spcPct val="90000"/>
+              </a:lnSpc>
+              <a:spcBef>
+                <a:spcPts val="1000"/>
+              </a:spcBef>
+              <a:spcAft>
+                <a:spcPts val="0"/>
+              </a:spcAft>
+              <a:buClrTx/>
+              <a:buSzTx/>
+              <a:buFont typeface="Arial" panose="020B0604020202020204" pitchFamily="34" charset="0"/>
+              <a:buNone/>
+              <a:tabLst/>
+              <a:defRPr/>
+            </a:pPr>
+            <a:endParaRPr lang="en-GB" dirty="0"/>
+          </a:p>
+          <a:p>
+            <a:pPr marL="228600" marR="0" lvl="0" indent="-228600" algn="ctr" defTabSz="914400" rtl="0" eaLnBrk="1" fontAlgn="auto" latinLnBrk="0" hangingPunct="1">
+              <a:lnSpc>
+                <a:spcPct val="90000"/>
+              </a:lnSpc>
+              <a:spcBef>
+                <a:spcPts val="1000"/>
+              </a:spcBef>
+              <a:spcAft>
+                <a:spcPts val="0"/>
+              </a:spcAft>
+              <a:buClrTx/>
+              <a:buSzTx/>
+              <a:buFont typeface="Arial" panose="020B0604020202020204" pitchFamily="34" charset="0"/>
+              <a:buNone/>
+              <a:tabLst/>
+              <a:defRPr/>
+            </a:pPr>
+            <a:r>
+              <a:rPr lang="en-GB" dirty="0"/>
+              <a:t>on the layout root element</a:t>
+            </a:r>
+          </a:p>
+        </p:txBody>
+      </p:sp>
+    </p:spTree>
+    <p:extLst>
+      <p:ext uri="{BB962C8B-B14F-4D97-AF65-F5344CB8AC3E}">
+        <p14:creationId xmlns:p14="http://schemas.microsoft.com/office/powerpoint/2010/main" val="654078270"/>
+      </p:ext>
+    </p:extLst>
+  </p:cSld>
+  <p:clrMapOvr>
+    <a:masterClrMapping/>
+  </p:clrMapOvr>
+</p:sldLayout>
+</file>
+
+<file path=ppt/slideLayouts/slideLayout13.xml><?xml version="1.0" encoding="utf-8"?>
 <p:sldLayout xmlns:a="http://schemas.openxmlformats.org/drawingml/2006/main" xmlns:r="http://schemas.openxmlformats.org/officeDocument/2006/relationships" xmlns:p="http://schemas.openxmlformats.org/presentationml/2006/main" type="title" preserve="1">
   <p:cSld name="Title Slide">
     <p:spTree>
@@ -14213,7 +14513,7 @@
           <a:p>
             <a:fld id="{99FB2E88-1E27-2243-AE12-8E9276940C7E}" type="datetimeFigureOut">
               <a:rPr lang="en-US" smtClean="0"/>
-              <a:t>10/26/25</a:t>
+              <a:t>5/6/26</a:t>
             </a:fld>
             <a:endParaRPr lang="en-US"/>
           </a:p>
@@ -14286,7 +14586,7 @@
 </p:sldLayout>
 </file>
 
-<file path=ppt/slideLayouts/slideLayout13.xml><?xml version="1.0" encoding="utf-8"?>
+<file path=ppt/slideLayouts/slideLayout14.xml><?xml version="1.0" encoding="utf-8"?>
 <p:sldLayout xmlns:a="http://schemas.openxmlformats.org/drawingml/2006/main" xmlns:r="http://schemas.openxmlformats.org/officeDocument/2006/relationships" xmlns:p="http://schemas.openxmlformats.org/presentationml/2006/main" type="obj" preserve="1">
   <p:cSld name="Title and Content">
     <p:spTree>
@@ -14413,7 +14713,7 @@
           <a:p>
             <a:fld id="{99FB2E88-1E27-2243-AE12-8E9276940C7E}" type="datetimeFigureOut">
               <a:rPr lang="en-US" smtClean="0"/>
-              <a:t>10/26/25</a:t>
+              <a:t>5/6/26</a:t>
             </a:fld>
             <a:endParaRPr lang="en-US"/>
           </a:p>
@@ -14486,7 +14786,7 @@
 </p:sldLayout>
 </file>
 
-<file path=ppt/slideLayouts/slideLayout14.xml><?xml version="1.0" encoding="utf-8"?>
+<file path=ppt/slideLayouts/slideLayout15.xml><?xml version="1.0" encoding="utf-8"?>
 <p:sldLayout xmlns:a="http://schemas.openxmlformats.org/drawingml/2006/main" xmlns:r="http://schemas.openxmlformats.org/officeDocument/2006/relationships" xmlns:p="http://schemas.openxmlformats.org/presentationml/2006/main" type="secHead" preserve="1">
   <p:cSld name="Section Header">
     <p:spTree>
@@ -14689,7 +14989,7 @@
           <a:p>
             <a:fld id="{99FB2E88-1E27-2243-AE12-8E9276940C7E}" type="datetimeFigureOut">
               <a:rPr lang="en-US" smtClean="0"/>
-              <a:t>10/26/25</a:t>
+              <a:t>5/6/26</a:t>
             </a:fld>
             <a:endParaRPr lang="en-US"/>
           </a:p>
@@ -14762,7 +15062,7 @@
 </p:sldLayout>
 </file>
 
-<file path=ppt/slideLayouts/slideLayout15.xml><?xml version="1.0" encoding="utf-8"?>
+<file path=ppt/slideLayouts/slideLayout16.xml><?xml version="1.0" encoding="utf-8"?>
 <p:sldLayout xmlns:a="http://schemas.openxmlformats.org/drawingml/2006/main" xmlns:r="http://schemas.openxmlformats.org/officeDocument/2006/relationships" xmlns:p="http://schemas.openxmlformats.org/presentationml/2006/main" type="twoObj" preserve="1">
   <p:cSld name="Two Content">
     <p:spTree>
@@ -14957,7 +15257,7 @@
           <a:p>
             <a:fld id="{99FB2E88-1E27-2243-AE12-8E9276940C7E}" type="datetimeFigureOut">
               <a:rPr lang="en-US" smtClean="0"/>
-              <a:t>10/26/25</a:t>
+              <a:t>5/6/26</a:t>
             </a:fld>
             <a:endParaRPr lang="en-US"/>
           </a:p>
@@ -15030,7 +15330,7 @@
 </p:sldLayout>
 </file>
 
-<file path=ppt/slideLayouts/slideLayout16.xml><?xml version="1.0" encoding="utf-8"?>
+<file path=ppt/slideLayouts/slideLayout17.xml><?xml version="1.0" encoding="utf-8"?>
 <p:sldLayout xmlns:a="http://schemas.openxmlformats.org/drawingml/2006/main" xmlns:r="http://schemas.openxmlformats.org/officeDocument/2006/relationships" xmlns:p="http://schemas.openxmlformats.org/presentationml/2006/main" type="twoTxTwoObj" preserve="1">
   <p:cSld name="Comparison">
     <p:spTree>
@@ -15372,7 +15672,7 @@
           <a:p>
             <a:fld id="{99FB2E88-1E27-2243-AE12-8E9276940C7E}" type="datetimeFigureOut">
               <a:rPr lang="en-US" smtClean="0"/>
-              <a:t>10/26/25</a:t>
+              <a:t>5/6/26</a:t>
             </a:fld>
             <a:endParaRPr lang="en-US"/>
           </a:p>
@@ -15445,7 +15745,7 @@
 </p:sldLayout>
 </file>
 
-<file path=ppt/slideLayouts/slideLayout17.xml><?xml version="1.0" encoding="utf-8"?>
+<file path=ppt/slideLayouts/slideLayout18.xml><?xml version="1.0" encoding="utf-8"?>
 <p:sldLayout xmlns:a="http://schemas.openxmlformats.org/drawingml/2006/main" xmlns:r="http://schemas.openxmlformats.org/officeDocument/2006/relationships" xmlns:p="http://schemas.openxmlformats.org/presentationml/2006/main" type="titleOnly" preserve="1">
   <p:cSld name="Title Only">
     <p:spTree>
@@ -15514,7 +15814,7 @@
           <a:p>
             <a:fld id="{99FB2E88-1E27-2243-AE12-8E9276940C7E}" type="datetimeFigureOut">
               <a:rPr lang="en-US" smtClean="0"/>
-              <a:t>10/26/25</a:t>
+              <a:t>5/6/26</a:t>
             </a:fld>
             <a:endParaRPr lang="en-US"/>
           </a:p>
@@ -15587,7 +15887,7 @@
 </p:sldLayout>
 </file>
 
-<file path=ppt/slideLayouts/slideLayout18.xml><?xml version="1.0" encoding="utf-8"?>
+<file path=ppt/slideLayouts/slideLayout19.xml><?xml version="1.0" encoding="utf-8"?>
 <p:sldLayout xmlns:a="http://schemas.openxmlformats.org/drawingml/2006/main" xmlns:r="http://schemas.openxmlformats.org/officeDocument/2006/relationships" xmlns:p="http://schemas.openxmlformats.org/presentationml/2006/main" type="blank" preserve="1">
   <p:cSld name="Blank">
     <p:spTree>
@@ -15627,7 +15927,7 @@
           <a:p>
             <a:fld id="{99FB2E88-1E27-2243-AE12-8E9276940C7E}" type="datetimeFigureOut">
               <a:rPr lang="en-US" smtClean="0"/>
-              <a:t>10/26/25</a:t>
+              <a:t>5/6/26</a:t>
             </a:fld>
             <a:endParaRPr lang="en-US"/>
           </a:p>
@@ -15700,7 +16000,207 @@
 </p:sldLayout>
 </file>
 
-<file path=ppt/slideLayouts/slideLayout19.xml><?xml version="1.0" encoding="utf-8"?>
+<file path=ppt/slideLayouts/slideLayout2.xml><?xml version="1.0" encoding="utf-8"?>
+<p:sldLayout xmlns:a="http://schemas.openxmlformats.org/drawingml/2006/main" xmlns:r="http://schemas.openxmlformats.org/officeDocument/2006/relationships" xmlns:p="http://schemas.openxmlformats.org/presentationml/2006/main" type="obj" preserve="1">
+  <p:cSld name="Title and Content">
+    <p:spTree>
+      <p:nvGrpSpPr>
+        <p:cNvPr id="1" name=""/>
+        <p:cNvGrpSpPr/>
+        <p:nvPr/>
+      </p:nvGrpSpPr>
+      <p:grpSpPr>
+        <a:xfrm>
+          <a:off x="0" y="0"/>
+          <a:ext cx="0" cy="0"/>
+          <a:chOff x="0" y="0"/>
+          <a:chExt cx="0" cy="0"/>
+        </a:xfrm>
+      </p:grpSpPr>
+      <p:sp>
+        <p:nvSpPr>
+          <p:cNvPr id="2" name="Title 1">
+            <a:extLst>
+              <a:ext uri="{FF2B5EF4-FFF2-40B4-BE49-F238E27FC236}">
+                <a16:creationId xmlns:a16="http://schemas.microsoft.com/office/drawing/2014/main" id="{3B8C287A-2E71-C50F-85B3-88F6316F2D14}"/>
+              </a:ext>
+            </a:extLst>
+          </p:cNvPr>
+          <p:cNvSpPr>
+            <a:spLocks noGrp="1"/>
+          </p:cNvSpPr>
+          <p:nvPr>
+            <p:ph type="title"/>
+          </p:nvPr>
+        </p:nvSpPr>
+        <p:spPr/>
+        <p:txBody>
+          <a:bodyPr/>
+          <a:lstStyle/>
+          <a:p>
+            <a:r>
+              <a:rPr lang="en-GB"/>
+              <a:t>Click to edit Master title style</a:t>
+            </a:r>
+            <a:endParaRPr lang="en-US"/>
+          </a:p>
+        </p:txBody>
+      </p:sp>
+      <p:sp>
+        <p:nvSpPr>
+          <p:cNvPr id="3" name="Content Placeholder 2">
+            <a:extLst>
+              <a:ext uri="{FF2B5EF4-FFF2-40B4-BE49-F238E27FC236}">
+                <a16:creationId xmlns:a16="http://schemas.microsoft.com/office/drawing/2014/main" id="{4110D3E7-CE46-128E-D575-4D9411BAA93B}"/>
+              </a:ext>
+            </a:extLst>
+          </p:cNvPr>
+          <p:cNvSpPr>
+            <a:spLocks noGrp="1"/>
+          </p:cNvSpPr>
+          <p:nvPr>
+            <p:ph idx="1"/>
+          </p:nvPr>
+        </p:nvSpPr>
+        <p:spPr/>
+        <p:txBody>
+          <a:bodyPr/>
+          <a:lstStyle/>
+          <a:p>
+            <a:pPr lvl="0"/>
+            <a:r>
+              <a:rPr lang="en-GB"/>
+              <a:t>Click to edit Master text styles</a:t>
+            </a:r>
+          </a:p>
+          <a:p>
+            <a:pPr lvl="1"/>
+            <a:r>
+              <a:rPr lang="en-GB"/>
+              <a:t>Second level</a:t>
+            </a:r>
+          </a:p>
+          <a:p>
+            <a:pPr lvl="2"/>
+            <a:r>
+              <a:rPr lang="en-GB"/>
+              <a:t>Third level</a:t>
+            </a:r>
+          </a:p>
+          <a:p>
+            <a:pPr lvl="3"/>
+            <a:r>
+              <a:rPr lang="en-GB"/>
+              <a:t>Fourth level</a:t>
+            </a:r>
+          </a:p>
+          <a:p>
+            <a:pPr lvl="4"/>
+            <a:r>
+              <a:rPr lang="en-GB"/>
+              <a:t>Fifth level</a:t>
+            </a:r>
+            <a:endParaRPr lang="en-US"/>
+          </a:p>
+        </p:txBody>
+      </p:sp>
+      <p:sp>
+        <p:nvSpPr>
+          <p:cNvPr id="4" name="Date Placeholder 3">
+            <a:extLst>
+              <a:ext uri="{FF2B5EF4-FFF2-40B4-BE49-F238E27FC236}">
+                <a16:creationId xmlns:a16="http://schemas.microsoft.com/office/drawing/2014/main" id="{A2D56A85-B71E-156A-1179-AE65148285A1}"/>
+              </a:ext>
+            </a:extLst>
+          </p:cNvPr>
+          <p:cNvSpPr>
+            <a:spLocks noGrp="1"/>
+          </p:cNvSpPr>
+          <p:nvPr>
+            <p:ph type="dt" sz="half" idx="10"/>
+          </p:nvPr>
+        </p:nvSpPr>
+        <p:spPr/>
+        <p:txBody>
+          <a:bodyPr/>
+          <a:lstStyle/>
+          <a:p>
+            <a:fld id="{99FB2E88-1E27-2243-AE12-8E9276940C7E}" type="datetimeFigureOut">
+              <a:rPr lang="en-US" smtClean="0"/>
+              <a:t>5/6/26</a:t>
+            </a:fld>
+            <a:endParaRPr lang="en-US"/>
+          </a:p>
+        </p:txBody>
+      </p:sp>
+      <p:sp>
+        <p:nvSpPr>
+          <p:cNvPr id="5" name="Footer Placeholder 4">
+            <a:extLst>
+              <a:ext uri="{FF2B5EF4-FFF2-40B4-BE49-F238E27FC236}">
+                <a16:creationId xmlns:a16="http://schemas.microsoft.com/office/drawing/2014/main" id="{00E4FA0A-0D5F-A29F-C55B-0B473B940294}"/>
+              </a:ext>
+            </a:extLst>
+          </p:cNvPr>
+          <p:cNvSpPr>
+            <a:spLocks noGrp="1"/>
+          </p:cNvSpPr>
+          <p:nvPr>
+            <p:ph type="ftr" sz="quarter" idx="11"/>
+          </p:nvPr>
+        </p:nvSpPr>
+        <p:spPr/>
+        <p:txBody>
+          <a:bodyPr/>
+          <a:lstStyle/>
+          <a:p>
+            <a:endParaRPr lang="en-US"/>
+          </a:p>
+        </p:txBody>
+      </p:sp>
+      <p:sp>
+        <p:nvSpPr>
+          <p:cNvPr id="6" name="Slide Number Placeholder 5">
+            <a:extLst>
+              <a:ext uri="{FF2B5EF4-FFF2-40B4-BE49-F238E27FC236}">
+                <a16:creationId xmlns:a16="http://schemas.microsoft.com/office/drawing/2014/main" id="{DC688D67-B9FE-C872-545A-CF84F1473DD1}"/>
+              </a:ext>
+            </a:extLst>
+          </p:cNvPr>
+          <p:cNvSpPr>
+            <a:spLocks noGrp="1"/>
+          </p:cNvSpPr>
+          <p:nvPr>
+            <p:ph type="sldNum" sz="quarter" idx="12"/>
+          </p:nvPr>
+        </p:nvSpPr>
+        <p:spPr/>
+        <p:txBody>
+          <a:bodyPr/>
+          <a:lstStyle/>
+          <a:p>
+            <a:fld id="{FB79F54A-05CE-C64E-B4BD-9FE99FCAD8A2}" type="slidenum">
+              <a:rPr lang="en-US" smtClean="0"/>
+              <a:t>‹#›</a:t>
+            </a:fld>
+            <a:endParaRPr lang="en-US"/>
+          </a:p>
+        </p:txBody>
+      </p:sp>
+    </p:spTree>
+    <p:extLst>
+      <p:ext uri="{BB962C8B-B14F-4D97-AF65-F5344CB8AC3E}">
+        <p14:creationId xmlns:p14="http://schemas.microsoft.com/office/powerpoint/2010/main" val="2558286708"/>
+      </p:ext>
+    </p:extLst>
+  </p:cSld>
+  <p:clrMapOvr>
+    <a:masterClrMapping/>
+  </p:clrMapOvr>
+</p:sldLayout>
+</file>
+
+<file path=ppt/slideLayouts/slideLayout20.xml><?xml version="1.0" encoding="utf-8"?>
 <p:sldLayout xmlns:a="http://schemas.openxmlformats.org/drawingml/2006/main" xmlns:r="http://schemas.openxmlformats.org/officeDocument/2006/relationships" xmlns:p="http://schemas.openxmlformats.org/presentationml/2006/main" type="objTx" preserve="1">
   <p:cSld name="Content with Caption">
     <p:spTree>
@@ -15940,7 +16440,7 @@
           <a:p>
             <a:fld id="{99FB2E88-1E27-2243-AE12-8E9276940C7E}" type="datetimeFigureOut">
               <a:rPr lang="en-US" smtClean="0"/>
-              <a:t>10/26/25</a:t>
+              <a:t>5/6/26</a:t>
             </a:fld>
             <a:endParaRPr lang="en-US"/>
           </a:p>
@@ -16013,207 +16513,7 @@
 </p:sldLayout>
 </file>
 
-<file path=ppt/slideLayouts/slideLayout2.xml><?xml version="1.0" encoding="utf-8"?>
-<p:sldLayout xmlns:a="http://schemas.openxmlformats.org/drawingml/2006/main" xmlns:r="http://schemas.openxmlformats.org/officeDocument/2006/relationships" xmlns:p="http://schemas.openxmlformats.org/presentationml/2006/main" type="obj" preserve="1">
-  <p:cSld name="Title and Content">
-    <p:spTree>
-      <p:nvGrpSpPr>
-        <p:cNvPr id="1" name=""/>
-        <p:cNvGrpSpPr/>
-        <p:nvPr/>
-      </p:nvGrpSpPr>
-      <p:grpSpPr>
-        <a:xfrm>
-          <a:off x="0" y="0"/>
-          <a:ext cx="0" cy="0"/>
-          <a:chOff x="0" y="0"/>
-          <a:chExt cx="0" cy="0"/>
-        </a:xfrm>
-      </p:grpSpPr>
-      <p:sp>
-        <p:nvSpPr>
-          <p:cNvPr id="2" name="Title 1">
-            <a:extLst>
-              <a:ext uri="{FF2B5EF4-FFF2-40B4-BE49-F238E27FC236}">
-                <a16:creationId xmlns:a16="http://schemas.microsoft.com/office/drawing/2014/main" id="{3B8C287A-2E71-C50F-85B3-88F6316F2D14}"/>
-              </a:ext>
-            </a:extLst>
-          </p:cNvPr>
-          <p:cNvSpPr>
-            <a:spLocks noGrp="1"/>
-          </p:cNvSpPr>
-          <p:nvPr>
-            <p:ph type="title"/>
-          </p:nvPr>
-        </p:nvSpPr>
-        <p:spPr/>
-        <p:txBody>
-          <a:bodyPr/>
-          <a:lstStyle/>
-          <a:p>
-            <a:r>
-              <a:rPr lang="en-GB"/>
-              <a:t>Click to edit Master title style</a:t>
-            </a:r>
-            <a:endParaRPr lang="en-US"/>
-          </a:p>
-        </p:txBody>
-      </p:sp>
-      <p:sp>
-        <p:nvSpPr>
-          <p:cNvPr id="3" name="Content Placeholder 2">
-            <a:extLst>
-              <a:ext uri="{FF2B5EF4-FFF2-40B4-BE49-F238E27FC236}">
-                <a16:creationId xmlns:a16="http://schemas.microsoft.com/office/drawing/2014/main" id="{4110D3E7-CE46-128E-D575-4D9411BAA93B}"/>
-              </a:ext>
-            </a:extLst>
-          </p:cNvPr>
-          <p:cNvSpPr>
-            <a:spLocks noGrp="1"/>
-          </p:cNvSpPr>
-          <p:nvPr>
-            <p:ph idx="1"/>
-          </p:nvPr>
-        </p:nvSpPr>
-        <p:spPr/>
-        <p:txBody>
-          <a:bodyPr/>
-          <a:lstStyle/>
-          <a:p>
-            <a:pPr lvl="0"/>
-            <a:r>
-              <a:rPr lang="en-GB"/>
-              <a:t>Click to edit Master text styles</a:t>
-            </a:r>
-          </a:p>
-          <a:p>
-            <a:pPr lvl="1"/>
-            <a:r>
-              <a:rPr lang="en-GB"/>
-              <a:t>Second level</a:t>
-            </a:r>
-          </a:p>
-          <a:p>
-            <a:pPr lvl="2"/>
-            <a:r>
-              <a:rPr lang="en-GB"/>
-              <a:t>Third level</a:t>
-            </a:r>
-          </a:p>
-          <a:p>
-            <a:pPr lvl="3"/>
-            <a:r>
-              <a:rPr lang="en-GB"/>
-              <a:t>Fourth level</a:t>
-            </a:r>
-          </a:p>
-          <a:p>
-            <a:pPr lvl="4"/>
-            <a:r>
-              <a:rPr lang="en-GB"/>
-              <a:t>Fifth level</a:t>
-            </a:r>
-            <a:endParaRPr lang="en-US"/>
-          </a:p>
-        </p:txBody>
-      </p:sp>
-      <p:sp>
-        <p:nvSpPr>
-          <p:cNvPr id="4" name="Date Placeholder 3">
-            <a:extLst>
-              <a:ext uri="{FF2B5EF4-FFF2-40B4-BE49-F238E27FC236}">
-                <a16:creationId xmlns:a16="http://schemas.microsoft.com/office/drawing/2014/main" id="{A2D56A85-B71E-156A-1179-AE65148285A1}"/>
-              </a:ext>
-            </a:extLst>
-          </p:cNvPr>
-          <p:cNvSpPr>
-            <a:spLocks noGrp="1"/>
-          </p:cNvSpPr>
-          <p:nvPr>
-            <p:ph type="dt" sz="half" idx="10"/>
-          </p:nvPr>
-        </p:nvSpPr>
-        <p:spPr/>
-        <p:txBody>
-          <a:bodyPr/>
-          <a:lstStyle/>
-          <a:p>
-            <a:fld id="{99FB2E88-1E27-2243-AE12-8E9276940C7E}" type="datetimeFigureOut">
-              <a:rPr lang="en-US" smtClean="0"/>
-              <a:t>10/26/25</a:t>
-            </a:fld>
-            <a:endParaRPr lang="en-US"/>
-          </a:p>
-        </p:txBody>
-      </p:sp>
-      <p:sp>
-        <p:nvSpPr>
-          <p:cNvPr id="5" name="Footer Placeholder 4">
-            <a:extLst>
-              <a:ext uri="{FF2B5EF4-FFF2-40B4-BE49-F238E27FC236}">
-                <a16:creationId xmlns:a16="http://schemas.microsoft.com/office/drawing/2014/main" id="{00E4FA0A-0D5F-A29F-C55B-0B473B940294}"/>
-              </a:ext>
-            </a:extLst>
-          </p:cNvPr>
-          <p:cNvSpPr>
-            <a:spLocks noGrp="1"/>
-          </p:cNvSpPr>
-          <p:nvPr>
-            <p:ph type="ftr" sz="quarter" idx="11"/>
-          </p:nvPr>
-        </p:nvSpPr>
-        <p:spPr/>
-        <p:txBody>
-          <a:bodyPr/>
-          <a:lstStyle/>
-          <a:p>
-            <a:endParaRPr lang="en-US"/>
-          </a:p>
-        </p:txBody>
-      </p:sp>
-      <p:sp>
-        <p:nvSpPr>
-          <p:cNvPr id="6" name="Slide Number Placeholder 5">
-            <a:extLst>
-              <a:ext uri="{FF2B5EF4-FFF2-40B4-BE49-F238E27FC236}">
-                <a16:creationId xmlns:a16="http://schemas.microsoft.com/office/drawing/2014/main" id="{DC688D67-B9FE-C872-545A-CF84F1473DD1}"/>
-              </a:ext>
-            </a:extLst>
-          </p:cNvPr>
-          <p:cNvSpPr>
-            <a:spLocks noGrp="1"/>
-          </p:cNvSpPr>
-          <p:nvPr>
-            <p:ph type="sldNum" sz="quarter" idx="12"/>
-          </p:nvPr>
-        </p:nvSpPr>
-        <p:spPr/>
-        <p:txBody>
-          <a:bodyPr/>
-          <a:lstStyle/>
-          <a:p>
-            <a:fld id="{FB79F54A-05CE-C64E-B4BD-9FE99FCAD8A2}" type="slidenum">
-              <a:rPr lang="en-US" smtClean="0"/>
-              <a:t>‹#›</a:t>
-            </a:fld>
-            <a:endParaRPr lang="en-US"/>
-          </a:p>
-        </p:txBody>
-      </p:sp>
-    </p:spTree>
-    <p:extLst>
-      <p:ext uri="{BB962C8B-B14F-4D97-AF65-F5344CB8AC3E}">
-        <p14:creationId xmlns:p14="http://schemas.microsoft.com/office/powerpoint/2010/main" val="2558286708"/>
-      </p:ext>
-    </p:extLst>
-  </p:cSld>
-  <p:clrMapOvr>
-    <a:masterClrMapping/>
-  </p:clrMapOvr>
-</p:sldLayout>
-</file>
-
-<file path=ppt/slideLayouts/slideLayout20.xml><?xml version="1.0" encoding="utf-8"?>
+<file path=ppt/slideLayouts/slideLayout21.xml><?xml version="1.0" encoding="utf-8"?>
 <p:sldLayout xmlns:a="http://schemas.openxmlformats.org/drawingml/2006/main" xmlns:r="http://schemas.openxmlformats.org/officeDocument/2006/relationships" xmlns:p="http://schemas.openxmlformats.org/presentationml/2006/main" type="picTx" preserve="1">
   <p:cSld name="Picture with Caption">
     <p:spTree>
@@ -16429,7 +16729,7 @@
           <a:p>
             <a:fld id="{99FB2E88-1E27-2243-AE12-8E9276940C7E}" type="datetimeFigureOut">
               <a:rPr lang="en-US" smtClean="0"/>
-              <a:t>10/26/25</a:t>
+              <a:t>5/6/26</a:t>
             </a:fld>
             <a:endParaRPr lang="en-US"/>
           </a:p>
@@ -16502,7 +16802,7 @@
 </p:sldLayout>
 </file>
 
-<file path=ppt/slideLayouts/slideLayout21.xml><?xml version="1.0" encoding="utf-8"?>
+<file path=ppt/slideLayouts/slideLayout22.xml><?xml version="1.0" encoding="utf-8"?>
 <p:sldLayout xmlns:a="http://schemas.openxmlformats.org/drawingml/2006/main" xmlns:r="http://schemas.openxmlformats.org/officeDocument/2006/relationships" xmlns:p="http://schemas.openxmlformats.org/presentationml/2006/main" type="vertTx" preserve="1">
   <p:cSld name="Title and Vertical Text">
     <p:spTree>
@@ -16629,7 +16929,7 @@
           <a:p>
             <a:fld id="{99FB2E88-1E27-2243-AE12-8E9276940C7E}" type="datetimeFigureOut">
               <a:rPr lang="en-US" smtClean="0"/>
-              <a:t>10/26/25</a:t>
+              <a:t>5/6/26</a:t>
             </a:fld>
             <a:endParaRPr lang="en-US"/>
           </a:p>
@@ -16702,7 +17002,7 @@
 </p:sldLayout>
 </file>
 
-<file path=ppt/slideLayouts/slideLayout22.xml><?xml version="1.0" encoding="utf-8"?>
+<file path=ppt/slideLayouts/slideLayout23.xml><?xml version="1.0" encoding="utf-8"?>
 <p:sldLayout xmlns:a="http://schemas.openxmlformats.org/drawingml/2006/main" xmlns:r="http://schemas.openxmlformats.org/officeDocument/2006/relationships" xmlns:p="http://schemas.openxmlformats.org/presentationml/2006/main" type="vertTitleAndTx" preserve="1">
   <p:cSld name="Vertical Title and Text">
     <p:spTree>
@@ -16839,7 +17139,7 @@
           <a:p>
             <a:fld id="{99FB2E88-1E27-2243-AE12-8E9276940C7E}" type="datetimeFigureOut">
               <a:rPr lang="en-US" smtClean="0"/>
-              <a:t>10/26/25</a:t>
+              <a:t>5/6/26</a:t>
             </a:fld>
             <a:endParaRPr lang="en-US"/>
           </a:p>
@@ -16912,7 +17212,7 @@
 </p:sldLayout>
 </file>
 
-<file path=ppt/slideLayouts/slideLayout23.xml><?xml version="1.0" encoding="utf-8"?>
+<file path=ppt/slideLayouts/slideLayout24.xml><?xml version="1.0" encoding="utf-8"?>
 <p:sldLayout xmlns:a="http://schemas.openxmlformats.org/drawingml/2006/main" xmlns:r="http://schemas.openxmlformats.org/officeDocument/2006/relationships" xmlns:p="http://schemas.openxmlformats.org/presentationml/2006/main" type="title" preserve="1">
   <p:cSld name="Title Slide">
     <p:spTree>
@@ -17065,7 +17365,7 @@
           <a:p>
             <a:fld id="{99FB2E88-1E27-2243-AE12-8E9276940C7E}" type="datetimeFigureOut">
               <a:rPr lang="en-US" smtClean="0"/>
-              <a:t>10/26/25</a:t>
+              <a:t>5/6/26</a:t>
             </a:fld>
             <a:endParaRPr lang="en-US"/>
           </a:p>
@@ -17138,7 +17438,7 @@
 </p:sldLayout>
 </file>
 
-<file path=ppt/slideLayouts/slideLayout24.xml><?xml version="1.0" encoding="utf-8"?>
+<file path=ppt/slideLayouts/slideLayout25.xml><?xml version="1.0" encoding="utf-8"?>
 <p:sldLayout xmlns:a="http://schemas.openxmlformats.org/drawingml/2006/main" xmlns:r="http://schemas.openxmlformats.org/officeDocument/2006/relationships" xmlns:p="http://schemas.openxmlformats.org/presentationml/2006/main" type="obj" preserve="1">
   <p:cSld name="Title and Content">
     <p:spTree>
@@ -17265,7 +17565,7 @@
           <a:p>
             <a:fld id="{99FB2E88-1E27-2243-AE12-8E9276940C7E}" type="datetimeFigureOut">
               <a:rPr lang="en-US" smtClean="0"/>
-              <a:t>10/26/25</a:t>
+              <a:t>5/6/26</a:t>
             </a:fld>
             <a:endParaRPr lang="en-US"/>
           </a:p>
@@ -17338,7 +17638,7 @@
 </p:sldLayout>
 </file>
 
-<file path=ppt/slideLayouts/slideLayout25.xml><?xml version="1.0" encoding="utf-8"?>
+<file path=ppt/slideLayouts/slideLayout26.xml><?xml version="1.0" encoding="utf-8"?>
 <p:sldLayout xmlns:a="http://schemas.openxmlformats.org/drawingml/2006/main" xmlns:r="http://schemas.openxmlformats.org/officeDocument/2006/relationships" xmlns:p="http://schemas.openxmlformats.org/presentationml/2006/main" type="secHead" preserve="1">
   <p:cSld name="Section Header">
     <p:spTree>
@@ -17541,7 +17841,7 @@
           <a:p>
             <a:fld id="{99FB2E88-1E27-2243-AE12-8E9276940C7E}" type="datetimeFigureOut">
               <a:rPr lang="en-US" smtClean="0"/>
-              <a:t>10/26/25</a:t>
+              <a:t>5/6/26</a:t>
             </a:fld>
             <a:endParaRPr lang="en-US"/>
           </a:p>
@@ -17614,7 +17914,7 @@
 </p:sldLayout>
 </file>
 
-<file path=ppt/slideLayouts/slideLayout26.xml><?xml version="1.0" encoding="utf-8"?>
+<file path=ppt/slideLayouts/slideLayout27.xml><?xml version="1.0" encoding="utf-8"?>
 <p:sldLayout xmlns:a="http://schemas.openxmlformats.org/drawingml/2006/main" xmlns:r="http://schemas.openxmlformats.org/officeDocument/2006/relationships" xmlns:p="http://schemas.openxmlformats.org/presentationml/2006/main" type="twoObj" preserve="1">
   <p:cSld name="Two Content">
     <p:spTree>
@@ -17809,7 +18109,7 @@
           <a:p>
             <a:fld id="{99FB2E88-1E27-2243-AE12-8E9276940C7E}" type="datetimeFigureOut">
               <a:rPr lang="en-US" smtClean="0"/>
-              <a:t>10/26/25</a:t>
+              <a:t>5/6/26</a:t>
             </a:fld>
             <a:endParaRPr lang="en-US"/>
           </a:p>
@@ -17882,7 +18182,7 @@
 </p:sldLayout>
 </file>
 
-<file path=ppt/slideLayouts/slideLayout27.xml><?xml version="1.0" encoding="utf-8"?>
+<file path=ppt/slideLayouts/slideLayout28.xml><?xml version="1.0" encoding="utf-8"?>
 <p:sldLayout xmlns:a="http://schemas.openxmlformats.org/drawingml/2006/main" xmlns:r="http://schemas.openxmlformats.org/officeDocument/2006/relationships" xmlns:p="http://schemas.openxmlformats.org/presentationml/2006/main" type="twoTxTwoObj" preserve="1">
   <p:cSld name="Comparison">
     <p:spTree>
@@ -18224,7 +18524,7 @@
           <a:p>
             <a:fld id="{99FB2E88-1E27-2243-AE12-8E9276940C7E}" type="datetimeFigureOut">
               <a:rPr lang="en-US" smtClean="0"/>
-              <a:t>10/26/25</a:t>
+              <a:t>5/6/26</a:t>
             </a:fld>
             <a:endParaRPr lang="en-US"/>
           </a:p>
@@ -18297,7 +18597,7 @@
 </p:sldLayout>
 </file>
 
-<file path=ppt/slideLayouts/slideLayout28.xml><?xml version="1.0" encoding="utf-8"?>
+<file path=ppt/slideLayouts/slideLayout29.xml><?xml version="1.0" encoding="utf-8"?>
 <p:sldLayout xmlns:a="http://schemas.openxmlformats.org/drawingml/2006/main" xmlns:r="http://schemas.openxmlformats.org/officeDocument/2006/relationships" xmlns:p="http://schemas.openxmlformats.org/presentationml/2006/main" type="titleOnly" preserve="1">
   <p:cSld name="Title Only">
     <p:spTree>
@@ -18366,7 +18666,7 @@
           <a:p>
             <a:fld id="{99FB2E88-1E27-2243-AE12-8E9276940C7E}" type="datetimeFigureOut">
               <a:rPr lang="en-US" smtClean="0"/>
-              <a:t>10/26/25</a:t>
+              <a:t>5/6/26</a:t>
             </a:fld>
             <a:endParaRPr lang="en-US"/>
           </a:p>
@@ -18430,119 +18730,6 @@
     <p:extLst>
       <p:ext uri="{BB962C8B-B14F-4D97-AF65-F5344CB8AC3E}">
         <p14:creationId xmlns:p14="http://schemas.microsoft.com/office/powerpoint/2010/main" val="3397386837"/>
-      </p:ext>
-    </p:extLst>
-  </p:cSld>
-  <p:clrMapOvr>
-    <a:masterClrMapping/>
-  </p:clrMapOvr>
-</p:sldLayout>
-</file>
-
-<file path=ppt/slideLayouts/slideLayout29.xml><?xml version="1.0" encoding="utf-8"?>
-<p:sldLayout xmlns:a="http://schemas.openxmlformats.org/drawingml/2006/main" xmlns:r="http://schemas.openxmlformats.org/officeDocument/2006/relationships" xmlns:p="http://schemas.openxmlformats.org/presentationml/2006/main" type="blank" preserve="1">
-  <p:cSld name="Blank">
-    <p:spTree>
-      <p:nvGrpSpPr>
-        <p:cNvPr id="1" name=""/>
-        <p:cNvGrpSpPr/>
-        <p:nvPr/>
-      </p:nvGrpSpPr>
-      <p:grpSpPr>
-        <a:xfrm>
-          <a:off x="0" y="0"/>
-          <a:ext cx="0" cy="0"/>
-          <a:chOff x="0" y="0"/>
-          <a:chExt cx="0" cy="0"/>
-        </a:xfrm>
-      </p:grpSpPr>
-      <p:sp>
-        <p:nvSpPr>
-          <p:cNvPr id="2" name="Date Placeholder 1">
-            <a:extLst>
-              <a:ext uri="{FF2B5EF4-FFF2-40B4-BE49-F238E27FC236}">
-                <a16:creationId xmlns:a16="http://schemas.microsoft.com/office/drawing/2014/main" id="{117698D7-0F9D-4481-18D5-D3A671DD8C1B}"/>
-              </a:ext>
-            </a:extLst>
-          </p:cNvPr>
-          <p:cNvSpPr>
-            <a:spLocks noGrp="1"/>
-          </p:cNvSpPr>
-          <p:nvPr>
-            <p:ph type="dt" sz="half" idx="10"/>
-          </p:nvPr>
-        </p:nvSpPr>
-        <p:spPr/>
-        <p:txBody>
-          <a:bodyPr/>
-          <a:lstStyle/>
-          <a:p>
-            <a:fld id="{99FB2E88-1E27-2243-AE12-8E9276940C7E}" type="datetimeFigureOut">
-              <a:rPr lang="en-US" smtClean="0"/>
-              <a:t>10/26/25</a:t>
-            </a:fld>
-            <a:endParaRPr lang="en-US"/>
-          </a:p>
-        </p:txBody>
-      </p:sp>
-      <p:sp>
-        <p:nvSpPr>
-          <p:cNvPr id="3" name="Footer Placeholder 2">
-            <a:extLst>
-              <a:ext uri="{FF2B5EF4-FFF2-40B4-BE49-F238E27FC236}">
-                <a16:creationId xmlns:a16="http://schemas.microsoft.com/office/drawing/2014/main" id="{3B37F211-D4DB-9900-55E9-F2B385925022}"/>
-              </a:ext>
-            </a:extLst>
-          </p:cNvPr>
-          <p:cNvSpPr>
-            <a:spLocks noGrp="1"/>
-          </p:cNvSpPr>
-          <p:nvPr>
-            <p:ph type="ftr" sz="quarter" idx="11"/>
-          </p:nvPr>
-        </p:nvSpPr>
-        <p:spPr/>
-        <p:txBody>
-          <a:bodyPr/>
-          <a:lstStyle/>
-          <a:p>
-            <a:endParaRPr lang="en-US"/>
-          </a:p>
-        </p:txBody>
-      </p:sp>
-      <p:sp>
-        <p:nvSpPr>
-          <p:cNvPr id="4" name="Slide Number Placeholder 3">
-            <a:extLst>
-              <a:ext uri="{FF2B5EF4-FFF2-40B4-BE49-F238E27FC236}">
-                <a16:creationId xmlns:a16="http://schemas.microsoft.com/office/drawing/2014/main" id="{05135D63-75E9-D37B-6B7F-EE4E9349D03D}"/>
-              </a:ext>
-            </a:extLst>
-          </p:cNvPr>
-          <p:cNvSpPr>
-            <a:spLocks noGrp="1"/>
-          </p:cNvSpPr>
-          <p:nvPr>
-            <p:ph type="sldNum" sz="quarter" idx="12"/>
-          </p:nvPr>
-        </p:nvSpPr>
-        <p:spPr/>
-        <p:txBody>
-          <a:bodyPr/>
-          <a:lstStyle/>
-          <a:p>
-            <a:fld id="{FB79F54A-05CE-C64E-B4BD-9FE99FCAD8A2}" type="slidenum">
-              <a:rPr lang="en-US" smtClean="0"/>
-              <a:t>‹#›</a:t>
-            </a:fld>
-            <a:endParaRPr lang="en-US"/>
-          </a:p>
-        </p:txBody>
-      </p:sp>
-    </p:spTree>
-    <p:extLst>
-      <p:ext uri="{BB962C8B-B14F-4D97-AF65-F5344CB8AC3E}">
-        <p14:creationId xmlns:p14="http://schemas.microsoft.com/office/powerpoint/2010/main" val="881586059"/>
       </p:ext>
     </p:extLst>
   </p:cSld>
@@ -18755,7 +18942,7 @@
           <a:p>
             <a:fld id="{99FB2E88-1E27-2243-AE12-8E9276940C7E}" type="datetimeFigureOut">
               <a:rPr lang="en-US" smtClean="0"/>
-              <a:t>10/26/25</a:t>
+              <a:t>5/6/26</a:t>
             </a:fld>
             <a:endParaRPr lang="en-US"/>
           </a:p>
@@ -18829,6 +19016,119 @@
 </file>
 
 <file path=ppt/slideLayouts/slideLayout30.xml><?xml version="1.0" encoding="utf-8"?>
+<p:sldLayout xmlns:a="http://schemas.openxmlformats.org/drawingml/2006/main" xmlns:r="http://schemas.openxmlformats.org/officeDocument/2006/relationships" xmlns:p="http://schemas.openxmlformats.org/presentationml/2006/main" type="blank" preserve="1">
+  <p:cSld name="Blank">
+    <p:spTree>
+      <p:nvGrpSpPr>
+        <p:cNvPr id="1" name=""/>
+        <p:cNvGrpSpPr/>
+        <p:nvPr/>
+      </p:nvGrpSpPr>
+      <p:grpSpPr>
+        <a:xfrm>
+          <a:off x="0" y="0"/>
+          <a:ext cx="0" cy="0"/>
+          <a:chOff x="0" y="0"/>
+          <a:chExt cx="0" cy="0"/>
+        </a:xfrm>
+      </p:grpSpPr>
+      <p:sp>
+        <p:nvSpPr>
+          <p:cNvPr id="2" name="Date Placeholder 1">
+            <a:extLst>
+              <a:ext uri="{FF2B5EF4-FFF2-40B4-BE49-F238E27FC236}">
+                <a16:creationId xmlns:a16="http://schemas.microsoft.com/office/drawing/2014/main" id="{117698D7-0F9D-4481-18D5-D3A671DD8C1B}"/>
+              </a:ext>
+            </a:extLst>
+          </p:cNvPr>
+          <p:cNvSpPr>
+            <a:spLocks noGrp="1"/>
+          </p:cNvSpPr>
+          <p:nvPr>
+            <p:ph type="dt" sz="half" idx="10"/>
+          </p:nvPr>
+        </p:nvSpPr>
+        <p:spPr/>
+        <p:txBody>
+          <a:bodyPr/>
+          <a:lstStyle/>
+          <a:p>
+            <a:fld id="{99FB2E88-1E27-2243-AE12-8E9276940C7E}" type="datetimeFigureOut">
+              <a:rPr lang="en-US" smtClean="0"/>
+              <a:t>5/6/26</a:t>
+            </a:fld>
+            <a:endParaRPr lang="en-US"/>
+          </a:p>
+        </p:txBody>
+      </p:sp>
+      <p:sp>
+        <p:nvSpPr>
+          <p:cNvPr id="3" name="Footer Placeholder 2">
+            <a:extLst>
+              <a:ext uri="{FF2B5EF4-FFF2-40B4-BE49-F238E27FC236}">
+                <a16:creationId xmlns:a16="http://schemas.microsoft.com/office/drawing/2014/main" id="{3B37F211-D4DB-9900-55E9-F2B385925022}"/>
+              </a:ext>
+            </a:extLst>
+          </p:cNvPr>
+          <p:cNvSpPr>
+            <a:spLocks noGrp="1"/>
+          </p:cNvSpPr>
+          <p:nvPr>
+            <p:ph type="ftr" sz="quarter" idx="11"/>
+          </p:nvPr>
+        </p:nvSpPr>
+        <p:spPr/>
+        <p:txBody>
+          <a:bodyPr/>
+          <a:lstStyle/>
+          <a:p>
+            <a:endParaRPr lang="en-US"/>
+          </a:p>
+        </p:txBody>
+      </p:sp>
+      <p:sp>
+        <p:nvSpPr>
+          <p:cNvPr id="4" name="Slide Number Placeholder 3">
+            <a:extLst>
+              <a:ext uri="{FF2B5EF4-FFF2-40B4-BE49-F238E27FC236}">
+                <a16:creationId xmlns:a16="http://schemas.microsoft.com/office/drawing/2014/main" id="{05135D63-75E9-D37B-6B7F-EE4E9349D03D}"/>
+              </a:ext>
+            </a:extLst>
+          </p:cNvPr>
+          <p:cNvSpPr>
+            <a:spLocks noGrp="1"/>
+          </p:cNvSpPr>
+          <p:nvPr>
+            <p:ph type="sldNum" sz="quarter" idx="12"/>
+          </p:nvPr>
+        </p:nvSpPr>
+        <p:spPr/>
+        <p:txBody>
+          <a:bodyPr/>
+          <a:lstStyle/>
+          <a:p>
+            <a:fld id="{FB79F54A-05CE-C64E-B4BD-9FE99FCAD8A2}" type="slidenum">
+              <a:rPr lang="en-US" smtClean="0"/>
+              <a:t>‹#›</a:t>
+            </a:fld>
+            <a:endParaRPr lang="en-US"/>
+          </a:p>
+        </p:txBody>
+      </p:sp>
+    </p:spTree>
+    <p:extLst>
+      <p:ext uri="{BB962C8B-B14F-4D97-AF65-F5344CB8AC3E}">
+        <p14:creationId xmlns:p14="http://schemas.microsoft.com/office/powerpoint/2010/main" val="881586059"/>
+      </p:ext>
+    </p:extLst>
+  </p:cSld>
+  <p:clrMapOvr>
+    <a:masterClrMapping/>
+  </p:clrMapOvr>
+</p:sldLayout>
+</file>
+
+<file path=ppt/slideLayouts/slideLayout31.xml><?xml version="1.0" encoding="utf-8"?>
 <p:sldLayout xmlns:a="http://schemas.openxmlformats.org/drawingml/2006/main" xmlns:r="http://schemas.openxmlformats.org/officeDocument/2006/relationships" xmlns:p="http://schemas.openxmlformats.org/presentationml/2006/main" type="objTx" preserve="1">
   <p:cSld name="Content with Caption">
     <p:spTree>
@@ -19068,7 +19368,7 @@
           <a:p>
             <a:fld id="{99FB2E88-1E27-2243-AE12-8E9276940C7E}" type="datetimeFigureOut">
               <a:rPr lang="en-US" smtClean="0"/>
-              <a:t>10/26/25</a:t>
+              <a:t>5/6/26</a:t>
             </a:fld>
             <a:endParaRPr lang="en-US"/>
           </a:p>
@@ -19141,7 +19441,7 @@
 </p:sldLayout>
 </file>
 
-<file path=ppt/slideLayouts/slideLayout31.xml><?xml version="1.0" encoding="utf-8"?>
+<file path=ppt/slideLayouts/slideLayout32.xml><?xml version="1.0" encoding="utf-8"?>
 <p:sldLayout xmlns:a="http://schemas.openxmlformats.org/drawingml/2006/main" xmlns:r="http://schemas.openxmlformats.org/officeDocument/2006/relationships" xmlns:p="http://schemas.openxmlformats.org/presentationml/2006/main" type="picTx" preserve="1">
   <p:cSld name="Picture with Caption">
     <p:spTree>
@@ -19357,7 +19657,7 @@
           <a:p>
             <a:fld id="{99FB2E88-1E27-2243-AE12-8E9276940C7E}" type="datetimeFigureOut">
               <a:rPr lang="en-US" smtClean="0"/>
-              <a:t>10/26/25</a:t>
+              <a:t>5/6/26</a:t>
             </a:fld>
             <a:endParaRPr lang="en-US"/>
           </a:p>
@@ -19430,7 +19730,7 @@
 </p:sldLayout>
 </file>
 
-<file path=ppt/slideLayouts/slideLayout32.xml><?xml version="1.0" encoding="utf-8"?>
+<file path=ppt/slideLayouts/slideLayout33.xml><?xml version="1.0" encoding="utf-8"?>
 <p:sldLayout xmlns:a="http://schemas.openxmlformats.org/drawingml/2006/main" xmlns:r="http://schemas.openxmlformats.org/officeDocument/2006/relationships" xmlns:p="http://schemas.openxmlformats.org/presentationml/2006/main" type="vertTx" preserve="1">
   <p:cSld name="Title and Vertical Text">
     <p:spTree>
@@ -19557,7 +19857,7 @@
           <a:p>
             <a:fld id="{99FB2E88-1E27-2243-AE12-8E9276940C7E}" type="datetimeFigureOut">
               <a:rPr lang="en-US" smtClean="0"/>
-              <a:t>10/26/25</a:t>
+              <a:t>5/6/26</a:t>
             </a:fld>
             <a:endParaRPr lang="en-US"/>
           </a:p>
@@ -19630,7 +19930,7 @@
 </p:sldLayout>
 </file>
 
-<file path=ppt/slideLayouts/slideLayout33.xml><?xml version="1.0" encoding="utf-8"?>
+<file path=ppt/slideLayouts/slideLayout34.xml><?xml version="1.0" encoding="utf-8"?>
 <p:sldLayout xmlns:a="http://schemas.openxmlformats.org/drawingml/2006/main" xmlns:r="http://schemas.openxmlformats.org/officeDocument/2006/relationships" xmlns:p="http://schemas.openxmlformats.org/presentationml/2006/main" type="vertTitleAndTx" preserve="1">
   <p:cSld name="Vertical Title and Text">
     <p:spTree>
@@ -19767,7 +20067,7 @@
           <a:p>
             <a:fld id="{99FB2E88-1E27-2243-AE12-8E9276940C7E}" type="datetimeFigureOut">
               <a:rPr lang="en-US" smtClean="0"/>
-              <a:t>10/26/25</a:t>
+              <a:t>5/6/26</a:t>
             </a:fld>
             <a:endParaRPr lang="en-US"/>
           </a:p>
@@ -20035,7 +20335,7 @@
           <a:p>
             <a:fld id="{99FB2E88-1E27-2243-AE12-8E9276940C7E}" type="datetimeFigureOut">
               <a:rPr lang="en-US" smtClean="0"/>
-              <a:t>10/26/25</a:t>
+              <a:t>5/6/26</a:t>
             </a:fld>
             <a:endParaRPr lang="en-US"/>
           </a:p>
@@ -20450,7 +20750,7 @@
           <a:p>
             <a:fld id="{99FB2E88-1E27-2243-AE12-8E9276940C7E}" type="datetimeFigureOut">
               <a:rPr lang="en-US" smtClean="0"/>
-              <a:t>10/26/25</a:t>
+              <a:t>5/6/26</a:t>
             </a:fld>
             <a:endParaRPr lang="en-US"/>
           </a:p>
@@ -20592,7 +20892,7 @@
           <a:p>
             <a:fld id="{99FB2E88-1E27-2243-AE12-8E9276940C7E}" type="datetimeFigureOut">
               <a:rPr lang="en-US" smtClean="0"/>
-              <a:t>10/26/25</a:t>
+              <a:t>5/6/26</a:t>
             </a:fld>
             <a:endParaRPr lang="en-US"/>
           </a:p>
@@ -20705,7 +21005,7 @@
           <a:p>
             <a:fld id="{99FB2E88-1E27-2243-AE12-8E9276940C7E}" type="datetimeFigureOut">
               <a:rPr lang="en-US" smtClean="0"/>
-              <a:t>10/26/25</a:t>
+              <a:t>5/6/26</a:t>
             </a:fld>
             <a:endParaRPr lang="en-US"/>
           </a:p>
@@ -21018,7 +21318,7 @@
           <a:p>
             <a:fld id="{99FB2E88-1E27-2243-AE12-8E9276940C7E}" type="datetimeFigureOut">
               <a:rPr lang="en-US" smtClean="0"/>
-              <a:t>10/26/25</a:t>
+              <a:t>5/6/26</a:t>
             </a:fld>
             <a:endParaRPr lang="en-US"/>
           </a:p>
@@ -21307,7 +21607,7 @@
           <a:p>
             <a:fld id="{99FB2E88-1E27-2243-AE12-8E9276940C7E}" type="datetimeFigureOut">
               <a:rPr lang="en-US" smtClean="0"/>
-              <a:t>10/26/25</a:t>
+              <a:t>5/6/26</a:t>
             </a:fld>
             <a:endParaRPr lang="en-US"/>
           </a:p>
@@ -21381,7 +21681,7 @@
 </file>
 
 <file path=ppt/slideMasters/slideMaster1.xml><?xml version="1.0" encoding="utf-8"?>
-<p:sldMaster xmlns:a="http://schemas.openxmlformats.org/drawingml/2006/main" xmlns:r="http://schemas.openxmlformats.org/officeDocument/2006/relationships" xmlns:p="http://schemas.openxmlformats.org/presentationml/2006/main">
+<p:sldMaster xmlns:a="http://schemas.openxmlformats.org/drawingml/2006/main" xmlns:r="http://schemas.openxmlformats.org/officeDocument/2006/relationships" xmlns:p="http://schemas.openxmlformats.org/presentationml/2006/main" preserve="1">
   <p:cSld>
     <p:bg>
       <p:bgRef idx="1001">
@@ -21550,7 +21850,7 @@
           <a:p>
             <a:fld id="{99FB2E88-1E27-2243-AE12-8E9276940C7E}" type="datetimeFigureOut">
               <a:rPr lang="en-US" smtClean="0"/>
-              <a:t>10/26/25</a:t>
+              <a:t>5/6/26</a:t>
             </a:fld>
             <a:endParaRPr lang="en-US"/>
           </a:p>
@@ -21666,6 +21966,7 @@
     <p:sldLayoutId id="2147483657" r:id="rId9"/>
     <p:sldLayoutId id="2147483658" r:id="rId10"/>
     <p:sldLayoutId id="2147483659" r:id="rId11"/>
+    <p:sldLayoutId id="2147483684" r:id="rId12"/>
   </p:sldLayoutIdLst>
   <p:txStyles>
     <p:titleStyle>
@@ -22120,7 +22421,7 @@
           <a:p>
             <a:fld id="{99FB2E88-1E27-2243-AE12-8E9276940C7E}" type="datetimeFigureOut">
               <a:rPr lang="en-US" smtClean="0"/>
-              <a:t>10/26/25</a:t>
+              <a:t>5/6/26</a:t>
             </a:fld>
             <a:endParaRPr lang="en-US"/>
           </a:p>
@@ -22690,7 +22991,7 @@
           <a:p>
             <a:fld id="{99FB2E88-1E27-2243-AE12-8E9276940C7E}" type="datetimeFigureOut">
               <a:rPr lang="en-US" smtClean="0"/>
-              <a:t>10/26/25</a:t>
+              <a:t>5/6/26</a:t>
             </a:fld>
             <a:endParaRPr lang="en-US"/>
           </a:p>

</xml_diff>